<commit_message>
add qr link to poster
</commit_message>
<xml_diff>
--- a/documents/dsp_poster_TranDuyAnh.pptx
+++ b/documents/dsp_poster_TranDuyAnh.pptx
@@ -4334,6 +4334,71 @@
           </a:prstGeom>
         </p:spPr>
       </p:pic>
+      <p:sp>
+        <p:nvSpPr>
+          <p:cNvPr id="5" name="TextBox 4">
+            <a:extLst>
+              <a:ext uri="{FF2B5EF4-FFF2-40B4-BE49-F238E27FC236}">
+                <a16:creationId xmlns:a16="http://schemas.microsoft.com/office/drawing/2014/main" id="{DB07AB49-D96C-B7A9-CA23-2E8B3C4C4734}"/>
+              </a:ext>
+            </a:extLst>
+          </p:cNvPr>
+          <p:cNvSpPr txBox="1"/>
+          <p:nvPr/>
+        </p:nvSpPr>
+        <p:spPr>
+          <a:xfrm>
+            <a:off x="26302940" y="2065718"/>
+            <a:ext cx="4058285" cy="369332"/>
+          </a:xfrm>
+          <a:prstGeom prst="rect">
+            <a:avLst/>
+          </a:prstGeom>
+          <a:noFill/>
+        </p:spPr>
+        <p:txBody>
+          <a:bodyPr wrap="square">
+            <a:spAutoFit/>
+          </a:bodyPr>
+          <a:lstStyle/>
+          <a:p>
+            <a:r>
+              <a:rPr lang="en-GB" sz="1800" dirty="0"/>
+              <a:t>A QR Code link to my video submission</a:t>
+            </a:r>
+          </a:p>
+        </p:txBody>
+      </p:sp>
+      <p:pic>
+        <p:nvPicPr>
+          <p:cNvPr id="22" name="Picture 21">
+            <a:extLst>
+              <a:ext uri="{FF2B5EF4-FFF2-40B4-BE49-F238E27FC236}">
+                <a16:creationId xmlns:a16="http://schemas.microsoft.com/office/drawing/2014/main" id="{F3923FB3-D74E-8745-CE7B-159D863784BB}"/>
+              </a:ext>
+            </a:extLst>
+          </p:cNvPr>
+          <p:cNvPicPr>
+            <a:picLocks noChangeAspect="1"/>
+          </p:cNvPicPr>
+          <p:nvPr/>
+        </p:nvPicPr>
+        <p:blipFill>
+          <a:blip r:embed="rId6"/>
+          <a:stretch>
+            <a:fillRect/>
+          </a:stretch>
+        </p:blipFill>
+        <p:spPr>
+          <a:xfrm>
+            <a:off x="27310572" y="368467"/>
+            <a:ext cx="1724266" cy="1590897"/>
+          </a:xfrm>
+          <a:prstGeom prst="rect">
+            <a:avLst/>
+          </a:prstGeom>
+        </p:spPr>
+      </p:pic>
     </p:spTree>
     <p:extLst>
       <p:ext uri="{BB962C8B-B14F-4D97-AF65-F5344CB8AC3E}">

</xml_diff>